<commit_message>
docs: mise à jour ai_codev_v3.pptx
Co-Authored-By: Claude Sonnet 4.6 <noreply@anthropic.com>
</commit_message>
<xml_diff>
--- a/documentation/ai_codev_v3.pptx
+++ b/documentation/ai_codev_v3.pptx
@@ -248,7 +248,7 @@
   </p:defaultTextStyle>
   <p:extLst>
     <p:ext uri="GoogleSlidesCustomDataVersion2">
-      <go:slidesCustomData xmlns:go="http://customooxmlschemas.google.com/" r:id="rId11" roundtripDataSignature="AMtx7mhxBEMRsd5kfMwI/SEhICv4vNtsRA=="/>
+      <go:slidesCustomData xmlns:go="http://customooxmlschemas.google.com/" r:id="rId11" roundtripDataSignature="AMtx7mjuFvC1qOYWhBbF9susbz80u1HMng=="/>
     </p:ext>
   </p:extLst>
 </p:presentation>
@@ -2055,7 +2055,7 @@
   <p:cSld>
     <p:spTree>
       <p:nvGrpSpPr>
-        <p:cNvPr id="137" name="Shape 137"/>
+        <p:cNvPr id="138" name="Shape 138"/>
         <p:cNvGrpSpPr/>
         <p:nvPr/>
       </p:nvGrpSpPr>
@@ -2069,7 +2069,7 @@
       </p:grpSpPr>
       <p:sp>
         <p:nvSpPr>
-          <p:cNvPr id="138" name="Google Shape;138;g3d21a676ba0_0_4:notes"/>
+          <p:cNvPr id="139" name="Google Shape;139;g3d21a676ba0_0_4:notes"/>
           <p:cNvSpPr/>
           <p:nvPr>
             <p:ph idx="2" type="sldImg"/>
@@ -2114,7 +2114,7 @@
       </p:sp>
       <p:sp>
         <p:nvSpPr>
-          <p:cNvPr id="139" name="Google Shape;139;g3d21a676ba0_0_4:notes"/>
+          <p:cNvPr id="140" name="Google Shape;140;g3d21a676ba0_0_4:notes"/>
           <p:cNvSpPr txBox="1"/>
           <p:nvPr>
             <p:ph idx="1" type="body"/>
@@ -2157,7 +2157,7 @@
       </p:sp>
       <p:sp>
         <p:nvSpPr>
-          <p:cNvPr id="140" name="Google Shape;140;g3d21a676ba0_0_4:notes"/>
+          <p:cNvPr id="141" name="Google Shape;141;g3d21a676ba0_0_4:notes"/>
           <p:cNvSpPr txBox="1"/>
           <p:nvPr>
             <p:ph idx="12" type="sldNum"/>
@@ -2212,7 +2212,7 @@
   <p:cSld>
     <p:spTree>
       <p:nvGrpSpPr>
-        <p:cNvPr id="155" name="Shape 155"/>
+        <p:cNvPr id="156" name="Shape 156"/>
         <p:cNvGrpSpPr/>
         <p:nvPr/>
       </p:nvGrpSpPr>
@@ -2226,7 +2226,7 @@
       </p:grpSpPr>
       <p:sp>
         <p:nvSpPr>
-          <p:cNvPr id="156" name="Google Shape;156;p5:notes"/>
+          <p:cNvPr id="157" name="Google Shape;157;p5:notes"/>
           <p:cNvSpPr/>
           <p:nvPr>
             <p:ph idx="2" type="sldImg"/>
@@ -2271,7 +2271,7 @@
       </p:sp>
       <p:sp>
         <p:nvSpPr>
-          <p:cNvPr id="157" name="Google Shape;157;p5:notes"/>
+          <p:cNvPr id="158" name="Google Shape;158;p5:notes"/>
           <p:cNvSpPr txBox="1"/>
           <p:nvPr>
             <p:ph idx="1" type="body"/>
@@ -2314,7 +2314,7 @@
       </p:sp>
       <p:sp>
         <p:nvSpPr>
-          <p:cNvPr id="158" name="Google Shape;158;p5:notes"/>
+          <p:cNvPr id="159" name="Google Shape;159;p5:notes"/>
           <p:cNvSpPr txBox="1"/>
           <p:nvPr>
             <p:ph idx="12" type="sldNum"/>
@@ -10225,6 +10225,48 @@
           </a:ln>
         </p:spPr>
       </p:cxnSp>
+      <p:sp>
+        <p:nvSpPr>
+          <p:cNvPr id="137" name="Google Shape;137;p4"/>
+          <p:cNvSpPr txBox="1"/>
+          <p:nvPr/>
+        </p:nvSpPr>
+        <p:spPr>
+          <a:xfrm>
+            <a:off x="5013825" y="4645350"/>
+            <a:ext cx="4000500" cy="402600"/>
+          </a:xfrm>
+          <a:prstGeom prst="rect">
+            <a:avLst/>
+          </a:prstGeom>
+          <a:noFill/>
+          <a:ln>
+            <a:noFill/>
+          </a:ln>
+        </p:spPr>
+        <p:txBody>
+          <a:bodyPr anchorCtr="0" anchor="t" bIns="91425" lIns="91425" spcFirstLastPara="1" rIns="91425" wrap="square" tIns="91425">
+            <a:noAutofit/>
+          </a:bodyPr>
+          <a:lstStyle/>
+          <a:p>
+            <a:pPr indent="0" lvl="0" marL="0" rtl="0" algn="l">
+              <a:spcBef>
+                <a:spcPts val="0"/>
+              </a:spcBef>
+              <a:spcAft>
+                <a:spcPts val="0"/>
+              </a:spcAft>
+              <a:buNone/>
+            </a:pPr>
+            <a:r>
+              <a:rPr lang="en-US"/>
+              <a:t>Total de temps passé : ~ 16 h dont 8 h de cours</a:t>
+            </a:r>
+            <a:endParaRPr/>
+          </a:p>
+        </p:txBody>
+      </p:sp>
     </p:spTree>
   </p:cSld>
   <p:clrMapOvr>
@@ -10245,7 +10287,7 @@
     </p:bg>
     <p:spTree>
       <p:nvGrpSpPr>
-        <p:cNvPr id="141" name="Shape 141"/>
+        <p:cNvPr id="142" name="Shape 142"/>
         <p:cNvGrpSpPr/>
         <p:nvPr/>
       </p:nvGrpSpPr>
@@ -10259,7 +10301,7 @@
       </p:grpSpPr>
       <p:sp>
         <p:nvSpPr>
-          <p:cNvPr id="142" name="Google Shape;142;g3d21a676ba0_0_4"/>
+          <p:cNvPr id="143" name="Google Shape;143;g3d21a676ba0_0_4"/>
           <p:cNvSpPr/>
           <p:nvPr/>
         </p:nvSpPr>
@@ -10308,7 +10350,7 @@
       </p:sp>
       <p:sp>
         <p:nvSpPr>
-          <p:cNvPr id="143" name="Google Shape;143;g3d21a676ba0_0_4"/>
+          <p:cNvPr id="144" name="Google Shape;144;g3d21a676ba0_0_4"/>
           <p:cNvSpPr/>
           <p:nvPr/>
         </p:nvSpPr>
@@ -10357,7 +10399,7 @@
       </p:sp>
       <p:sp>
         <p:nvSpPr>
-          <p:cNvPr id="144" name="Google Shape;144;g3d21a676ba0_0_4"/>
+          <p:cNvPr id="145" name="Google Shape;145;g3d21a676ba0_0_4"/>
           <p:cNvSpPr/>
           <p:nvPr/>
         </p:nvSpPr>
@@ -10456,7 +10498,7 @@
       </p:sp>
       <p:sp>
         <p:nvSpPr>
-          <p:cNvPr id="145" name="Google Shape;145;g3d21a676ba0_0_4"/>
+          <p:cNvPr id="146" name="Google Shape;146;g3d21a676ba0_0_4"/>
           <p:cNvSpPr/>
           <p:nvPr/>
         </p:nvSpPr>
@@ -10512,7 +10554,7 @@
       </p:sp>
       <p:sp>
         <p:nvSpPr>
-          <p:cNvPr id="146" name="Google Shape;146;g3d21a676ba0_0_4"/>
+          <p:cNvPr id="147" name="Google Shape;147;g3d21a676ba0_0_4"/>
           <p:cNvSpPr/>
           <p:nvPr/>
         </p:nvSpPr>
@@ -10561,7 +10603,7 @@
       </p:sp>
       <p:sp>
         <p:nvSpPr>
-          <p:cNvPr id="147" name="Google Shape;147;g3d21a676ba0_0_4"/>
+          <p:cNvPr id="148" name="Google Shape;148;g3d21a676ba0_0_4"/>
           <p:cNvSpPr/>
           <p:nvPr/>
         </p:nvSpPr>
@@ -10667,7 +10709,7 @@
       </p:sp>
       <p:sp>
         <p:nvSpPr>
-          <p:cNvPr id="148" name="Google Shape;148;g3d21a676ba0_0_4"/>
+          <p:cNvPr id="149" name="Google Shape;149;g3d21a676ba0_0_4"/>
           <p:cNvSpPr/>
           <p:nvPr/>
         </p:nvSpPr>
@@ -10730,7 +10772,7 @@
       </p:sp>
       <p:sp>
         <p:nvSpPr>
-          <p:cNvPr id="149" name="Google Shape;149;g3d21a676ba0_0_4"/>
+          <p:cNvPr id="150" name="Google Shape;150;g3d21a676ba0_0_4"/>
           <p:cNvSpPr/>
           <p:nvPr/>
         </p:nvSpPr>
@@ -10786,7 +10828,7 @@
       </p:sp>
       <p:sp>
         <p:nvSpPr>
-          <p:cNvPr id="150" name="Google Shape;150;g3d21a676ba0_0_4"/>
+          <p:cNvPr id="151" name="Google Shape;151;g3d21a676ba0_0_4"/>
           <p:cNvSpPr/>
           <p:nvPr/>
         </p:nvSpPr>
@@ -10835,7 +10877,7 @@
       </p:sp>
       <p:sp>
         <p:nvSpPr>
-          <p:cNvPr id="151" name="Google Shape;151;g3d21a676ba0_0_4"/>
+          <p:cNvPr id="152" name="Google Shape;152;g3d21a676ba0_0_4"/>
           <p:cNvSpPr/>
           <p:nvPr/>
         </p:nvSpPr>
@@ -10922,7 +10964,7 @@
       </p:sp>
       <p:pic>
         <p:nvPicPr>
-          <p:cNvPr id="152" name="Google Shape;152;g3d21a676ba0_0_4"/>
+          <p:cNvPr id="153" name="Google Shape;153;g3d21a676ba0_0_4"/>
           <p:cNvPicPr preferRelativeResize="0"/>
           <p:nvPr/>
         </p:nvPicPr>
@@ -10950,7 +10992,7 @@
       </p:pic>
       <p:pic>
         <p:nvPicPr>
-          <p:cNvPr id="153" name="Google Shape;153;g3d21a676ba0_0_4"/>
+          <p:cNvPr id="154" name="Google Shape;154;g3d21a676ba0_0_4"/>
           <p:cNvPicPr preferRelativeResize="0"/>
           <p:nvPr/>
         </p:nvPicPr>
@@ -10978,7 +11020,7 @@
       </p:pic>
       <p:pic>
         <p:nvPicPr>
-          <p:cNvPr id="154" name="Google Shape;154;g3d21a676ba0_0_4" title="output-2.gif"/>
+          <p:cNvPr id="155" name="Google Shape;155;g3d21a676ba0_0_4" title="output-2.gif"/>
           <p:cNvPicPr preferRelativeResize="0"/>
           <p:nvPr/>
         </p:nvPicPr>
@@ -11024,7 +11066,7 @@
     </p:bg>
     <p:spTree>
       <p:nvGrpSpPr>
-        <p:cNvPr id="159" name="Shape 159"/>
+        <p:cNvPr id="160" name="Shape 160"/>
         <p:cNvGrpSpPr/>
         <p:nvPr/>
       </p:nvGrpSpPr>
@@ -11038,7 +11080,7 @@
       </p:grpSpPr>
       <p:sp>
         <p:nvSpPr>
-          <p:cNvPr id="160" name="Google Shape;160;p5"/>
+          <p:cNvPr id="161" name="Google Shape;161;p5"/>
           <p:cNvSpPr/>
           <p:nvPr/>
         </p:nvSpPr>
@@ -11087,7 +11129,7 @@
       </p:sp>
       <p:sp>
         <p:nvSpPr>
-          <p:cNvPr id="161" name="Google Shape;161;p5"/>
+          <p:cNvPr id="162" name="Google Shape;162;p5"/>
           <p:cNvSpPr/>
           <p:nvPr/>
         </p:nvSpPr>
@@ -11136,7 +11178,7 @@
       </p:sp>
       <p:sp>
         <p:nvSpPr>
-          <p:cNvPr id="162" name="Google Shape;162;p5"/>
+          <p:cNvPr id="163" name="Google Shape;163;p5"/>
           <p:cNvSpPr/>
           <p:nvPr/>
         </p:nvSpPr>
@@ -11223,7 +11265,7 @@
       </p:sp>
       <p:sp>
         <p:nvSpPr>
-          <p:cNvPr id="163" name="Google Shape;163;p5"/>
+          <p:cNvPr id="164" name="Google Shape;164;p5"/>
           <p:cNvSpPr/>
           <p:nvPr/>
         </p:nvSpPr>
@@ -11279,7 +11321,7 @@
       </p:sp>
       <p:sp>
         <p:nvSpPr>
-          <p:cNvPr id="164" name="Google Shape;164;p5"/>
+          <p:cNvPr id="165" name="Google Shape;165;p5"/>
           <p:cNvSpPr/>
           <p:nvPr/>
         </p:nvSpPr>
@@ -11328,7 +11370,7 @@
       </p:sp>
       <p:sp>
         <p:nvSpPr>
-          <p:cNvPr id="165" name="Google Shape;165;p5"/>
+          <p:cNvPr id="166" name="Google Shape;166;p5"/>
           <p:cNvSpPr/>
           <p:nvPr/>
         </p:nvSpPr>
@@ -11391,7 +11433,7 @@
       </p:sp>
       <p:sp>
         <p:nvSpPr>
-          <p:cNvPr id="166" name="Google Shape;166;p5"/>
+          <p:cNvPr id="167" name="Google Shape;167;p5"/>
           <p:cNvSpPr/>
           <p:nvPr/>
         </p:nvSpPr>
@@ -11497,7 +11539,7 @@
       </p:sp>
       <p:sp>
         <p:nvSpPr>
-          <p:cNvPr id="167" name="Google Shape;167;p5"/>
+          <p:cNvPr id="168" name="Google Shape;168;p5"/>
           <p:cNvSpPr/>
           <p:nvPr/>
         </p:nvSpPr>
@@ -11553,7 +11595,7 @@
       </p:sp>
       <p:sp>
         <p:nvSpPr>
-          <p:cNvPr id="168" name="Google Shape;168;p5"/>
+          <p:cNvPr id="169" name="Google Shape;169;p5"/>
           <p:cNvSpPr/>
           <p:nvPr/>
         </p:nvSpPr>
@@ -11602,7 +11644,7 @@
       </p:sp>
       <p:sp>
         <p:nvSpPr>
-          <p:cNvPr id="169" name="Google Shape;169;p5"/>
+          <p:cNvPr id="170" name="Google Shape;170;p5"/>
           <p:cNvSpPr/>
           <p:nvPr/>
         </p:nvSpPr>
@@ -11665,7 +11707,7 @@
       </p:sp>
       <p:sp>
         <p:nvSpPr>
-          <p:cNvPr id="170" name="Google Shape;170;p5"/>
+          <p:cNvPr id="171" name="Google Shape;171;p5"/>
           <p:cNvSpPr/>
           <p:nvPr/>
         </p:nvSpPr>
@@ -11771,7 +11813,7 @@
       </p:sp>
       <p:sp>
         <p:nvSpPr>
-          <p:cNvPr id="171" name="Google Shape;171;p5"/>
+          <p:cNvPr id="172" name="Google Shape;172;p5"/>
           <p:cNvSpPr/>
           <p:nvPr/>
         </p:nvSpPr>
@@ -11827,7 +11869,7 @@
       </p:sp>
       <p:sp>
         <p:nvSpPr>
-          <p:cNvPr id="172" name="Google Shape;172;p5"/>
+          <p:cNvPr id="173" name="Google Shape;173;p5"/>
           <p:cNvSpPr/>
           <p:nvPr/>
         </p:nvSpPr>
@@ -11876,7 +11918,7 @@
       </p:sp>
       <p:sp>
         <p:nvSpPr>
-          <p:cNvPr id="173" name="Google Shape;173;p5"/>
+          <p:cNvPr id="174" name="Google Shape;174;p5"/>
           <p:cNvSpPr/>
           <p:nvPr/>
         </p:nvSpPr>
@@ -11939,7 +11981,7 @@
       </p:sp>
       <p:sp>
         <p:nvSpPr>
-          <p:cNvPr id="174" name="Google Shape;174;p5"/>
+          <p:cNvPr id="175" name="Google Shape;175;p5"/>
           <p:cNvSpPr/>
           <p:nvPr/>
         </p:nvSpPr>
@@ -12045,7 +12087,7 @@
       </p:sp>
       <p:sp>
         <p:nvSpPr>
-          <p:cNvPr id="175" name="Google Shape;175;p5"/>
+          <p:cNvPr id="176" name="Google Shape;176;p5"/>
           <p:cNvSpPr/>
           <p:nvPr/>
         </p:nvSpPr>
@@ -12101,7 +12143,7 @@
       </p:sp>
       <p:sp>
         <p:nvSpPr>
-          <p:cNvPr id="176" name="Google Shape;176;p5"/>
+          <p:cNvPr id="177" name="Google Shape;177;p5"/>
           <p:cNvSpPr/>
           <p:nvPr/>
         </p:nvSpPr>
@@ -12150,7 +12192,7 @@
       </p:sp>
       <p:sp>
         <p:nvSpPr>
-          <p:cNvPr id="177" name="Google Shape;177;p5"/>
+          <p:cNvPr id="178" name="Google Shape;178;p5"/>
           <p:cNvSpPr/>
           <p:nvPr/>
         </p:nvSpPr>
@@ -12213,7 +12255,7 @@
       </p:sp>
       <p:sp>
         <p:nvSpPr>
-          <p:cNvPr id="178" name="Google Shape;178;p5"/>
+          <p:cNvPr id="179" name="Google Shape;179;p5"/>
           <p:cNvSpPr/>
           <p:nvPr/>
         </p:nvSpPr>
@@ -12319,7 +12361,7 @@
       </p:sp>
       <p:sp>
         <p:nvSpPr>
-          <p:cNvPr id="179" name="Google Shape;179;p5"/>
+          <p:cNvPr id="180" name="Google Shape;180;p5"/>
           <p:cNvSpPr/>
           <p:nvPr/>
         </p:nvSpPr>
@@ -12375,7 +12417,7 @@
       </p:sp>
       <p:sp>
         <p:nvSpPr>
-          <p:cNvPr id="180" name="Google Shape;180;p5"/>
+          <p:cNvPr id="181" name="Google Shape;181;p5"/>
           <p:cNvSpPr/>
           <p:nvPr/>
         </p:nvSpPr>
@@ -12424,7 +12466,7 @@
       </p:sp>
       <p:sp>
         <p:nvSpPr>
-          <p:cNvPr id="181" name="Google Shape;181;p5"/>
+          <p:cNvPr id="182" name="Google Shape;182;p5"/>
           <p:cNvSpPr/>
           <p:nvPr/>
         </p:nvSpPr>
@@ -12487,7 +12529,7 @@
       </p:sp>
       <p:sp>
         <p:nvSpPr>
-          <p:cNvPr id="182" name="Google Shape;182;p5"/>
+          <p:cNvPr id="183" name="Google Shape;183;p5"/>
           <p:cNvSpPr/>
           <p:nvPr/>
         </p:nvSpPr>
@@ -12633,7 +12675,7 @@
       </p:sp>
       <p:sp>
         <p:nvSpPr>
-          <p:cNvPr id="183" name="Google Shape;183;p5"/>
+          <p:cNvPr id="184" name="Google Shape;184;p5"/>
           <p:cNvSpPr/>
           <p:nvPr/>
         </p:nvSpPr>
@@ -12689,7 +12731,7 @@
       </p:sp>
       <p:sp>
         <p:nvSpPr>
-          <p:cNvPr id="184" name="Google Shape;184;p5"/>
+          <p:cNvPr id="185" name="Google Shape;185;p5"/>
           <p:cNvSpPr/>
           <p:nvPr/>
         </p:nvSpPr>
@@ -12738,7 +12780,7 @@
       </p:sp>
       <p:sp>
         <p:nvSpPr>
-          <p:cNvPr id="185" name="Google Shape;185;p5"/>
+          <p:cNvPr id="186" name="Google Shape;186;p5"/>
           <p:cNvSpPr/>
           <p:nvPr/>
         </p:nvSpPr>
@@ -12801,7 +12843,7 @@
       </p:sp>
       <p:sp>
         <p:nvSpPr>
-          <p:cNvPr id="186" name="Google Shape;186;p5"/>
+          <p:cNvPr id="187" name="Google Shape;187;p5"/>
           <p:cNvSpPr/>
           <p:nvPr/>
         </p:nvSpPr>

</xml_diff>

<commit_message>
docs: mise à jour présentation ai_codev_v3
Co-Authored-By: Claude Sonnet 4.6 <noreply@anthropic.com>
</commit_message>
<xml_diff>
--- a/documentation/ai_codev_v3.pptx
+++ b/documentation/ai_codev_v3.pptx
@@ -248,7 +248,7 @@
   </p:defaultTextStyle>
   <p:extLst>
     <p:ext uri="GoogleSlidesCustomDataVersion2">
-      <go:slidesCustomData xmlns:go="http://customooxmlschemas.google.com/" r:id="rId11" roundtripDataSignature="AMtx7mhxBEMRsd5kfMwI/SEhICv4vNtsRA=="/>
+      <go:slidesCustomData xmlns:go="http://customooxmlschemas.google.com/" r:id="rId11" roundtripDataSignature="AMtx7mj9osW58/oT9Q1HQ5VPHprZkXnK6g=="/>
     </p:ext>
   </p:extLst>
 </p:presentation>
@@ -1584,7 +1584,7 @@
   <p:cSld>
     <p:spTree>
       <p:nvGrpSpPr>
-        <p:cNvPr id="23" name="Shape 23"/>
+        <p:cNvPr id="24" name="Shape 24"/>
         <p:cNvGrpSpPr/>
         <p:nvPr/>
       </p:nvGrpSpPr>
@@ -1598,7 +1598,7 @@
       </p:grpSpPr>
       <p:sp>
         <p:nvSpPr>
-          <p:cNvPr id="24" name="Google Shape;24;p2:notes"/>
+          <p:cNvPr id="25" name="Google Shape;25;p2:notes"/>
           <p:cNvSpPr/>
           <p:nvPr>
             <p:ph idx="2" type="sldImg"/>
@@ -1643,7 +1643,7 @@
       </p:sp>
       <p:sp>
         <p:nvSpPr>
-          <p:cNvPr id="25" name="Google Shape;25;p2:notes"/>
+          <p:cNvPr id="26" name="Google Shape;26;p2:notes"/>
           <p:cNvSpPr txBox="1"/>
           <p:nvPr>
             <p:ph idx="1" type="body"/>
@@ -1686,7 +1686,7 @@
       </p:sp>
       <p:sp>
         <p:nvSpPr>
-          <p:cNvPr id="26" name="Google Shape;26;p2:notes"/>
+          <p:cNvPr id="27" name="Google Shape;27;p2:notes"/>
           <p:cNvSpPr txBox="1"/>
           <p:nvPr>
             <p:ph idx="12" type="sldNum"/>
@@ -1741,7 +1741,7 @@
   <p:cSld>
     <p:spTree>
       <p:nvGrpSpPr>
-        <p:cNvPr id="60" name="Shape 60"/>
+        <p:cNvPr id="61" name="Shape 61"/>
         <p:cNvGrpSpPr/>
         <p:nvPr/>
       </p:nvGrpSpPr>
@@ -1755,7 +1755,7 @@
       </p:grpSpPr>
       <p:sp>
         <p:nvSpPr>
-          <p:cNvPr id="61" name="Google Shape;61;p3:notes"/>
+          <p:cNvPr id="62" name="Google Shape;62;p3:notes"/>
           <p:cNvSpPr/>
           <p:nvPr>
             <p:ph idx="2" type="sldImg"/>
@@ -1800,7 +1800,7 @@
       </p:sp>
       <p:sp>
         <p:nvSpPr>
-          <p:cNvPr id="62" name="Google Shape;62;p3:notes"/>
+          <p:cNvPr id="63" name="Google Shape;63;p3:notes"/>
           <p:cNvSpPr txBox="1"/>
           <p:nvPr>
             <p:ph idx="1" type="body"/>
@@ -1843,7 +1843,7 @@
       </p:sp>
       <p:sp>
         <p:nvSpPr>
-          <p:cNvPr id="63" name="Google Shape;63;p3:notes"/>
+          <p:cNvPr id="64" name="Google Shape;64;p3:notes"/>
           <p:cNvSpPr txBox="1"/>
           <p:nvPr>
             <p:ph idx="12" type="sldNum"/>
@@ -1898,7 +1898,7 @@
   <p:cSld>
     <p:spTree>
       <p:nvGrpSpPr>
-        <p:cNvPr id="93" name="Shape 93"/>
+        <p:cNvPr id="94" name="Shape 94"/>
         <p:cNvGrpSpPr/>
         <p:nvPr/>
       </p:nvGrpSpPr>
@@ -1912,7 +1912,7 @@
       </p:grpSpPr>
       <p:sp>
         <p:nvSpPr>
-          <p:cNvPr id="94" name="Google Shape;94;p4:notes"/>
+          <p:cNvPr id="95" name="Google Shape;95;p4:notes"/>
           <p:cNvSpPr/>
           <p:nvPr>
             <p:ph idx="2" type="sldImg"/>
@@ -1957,7 +1957,7 @@
       </p:sp>
       <p:sp>
         <p:nvSpPr>
-          <p:cNvPr id="95" name="Google Shape;95;p4:notes"/>
+          <p:cNvPr id="96" name="Google Shape;96;p4:notes"/>
           <p:cNvSpPr txBox="1"/>
           <p:nvPr>
             <p:ph idx="1" type="body"/>
@@ -2000,7 +2000,7 @@
       </p:sp>
       <p:sp>
         <p:nvSpPr>
-          <p:cNvPr id="96" name="Google Shape;96;p4:notes"/>
+          <p:cNvPr id="97" name="Google Shape;97;p4:notes"/>
           <p:cNvSpPr txBox="1"/>
           <p:nvPr>
             <p:ph idx="12" type="sldNum"/>
@@ -2055,7 +2055,7 @@
   <p:cSld>
     <p:spTree>
       <p:nvGrpSpPr>
-        <p:cNvPr id="137" name="Shape 137"/>
+        <p:cNvPr id="139" name="Shape 139"/>
         <p:cNvGrpSpPr/>
         <p:nvPr/>
       </p:nvGrpSpPr>
@@ -2069,7 +2069,7 @@
       </p:grpSpPr>
       <p:sp>
         <p:nvSpPr>
-          <p:cNvPr id="138" name="Google Shape;138;g3d21a676ba0_0_4:notes"/>
+          <p:cNvPr id="140" name="Google Shape;140;g3d21a676ba0_0_4:notes"/>
           <p:cNvSpPr/>
           <p:nvPr>
             <p:ph idx="2" type="sldImg"/>
@@ -2114,7 +2114,7 @@
       </p:sp>
       <p:sp>
         <p:nvSpPr>
-          <p:cNvPr id="139" name="Google Shape;139;g3d21a676ba0_0_4:notes"/>
+          <p:cNvPr id="141" name="Google Shape;141;g3d21a676ba0_0_4:notes"/>
           <p:cNvSpPr txBox="1"/>
           <p:nvPr>
             <p:ph idx="1" type="body"/>
@@ -2157,7 +2157,7 @@
       </p:sp>
       <p:sp>
         <p:nvSpPr>
-          <p:cNvPr id="140" name="Google Shape;140;g3d21a676ba0_0_4:notes"/>
+          <p:cNvPr id="142" name="Google Shape;142;g3d21a676ba0_0_4:notes"/>
           <p:cNvSpPr txBox="1"/>
           <p:nvPr>
             <p:ph idx="12" type="sldNum"/>
@@ -2212,7 +2212,7 @@
   <p:cSld>
     <p:spTree>
       <p:nvGrpSpPr>
-        <p:cNvPr id="155" name="Shape 155"/>
+        <p:cNvPr id="157" name="Shape 157"/>
         <p:cNvGrpSpPr/>
         <p:nvPr/>
       </p:nvGrpSpPr>
@@ -2226,7 +2226,7 @@
       </p:grpSpPr>
       <p:sp>
         <p:nvSpPr>
-          <p:cNvPr id="156" name="Google Shape;156;p5:notes"/>
+          <p:cNvPr id="158" name="Google Shape;158;p5:notes"/>
           <p:cNvSpPr/>
           <p:nvPr>
             <p:ph idx="2" type="sldImg"/>
@@ -2271,7 +2271,7 @@
       </p:sp>
       <p:sp>
         <p:nvSpPr>
-          <p:cNvPr id="157" name="Google Shape;157;p5:notes"/>
+          <p:cNvPr id="159" name="Google Shape;159;p5:notes"/>
           <p:cNvSpPr txBox="1"/>
           <p:nvPr>
             <p:ph idx="1" type="body"/>
@@ -2314,7 +2314,7 @@
       </p:sp>
       <p:sp>
         <p:nvSpPr>
-          <p:cNvPr id="158" name="Google Shape;158;p5:notes"/>
+          <p:cNvPr id="160" name="Google Shape;160;p5:notes"/>
           <p:cNvSpPr txBox="1"/>
           <p:nvPr>
             <p:ph idx="12" type="sldNum"/>
@@ -3251,7 +3251,7 @@
         <p:spPr>
           <a:xfrm>
             <a:off x="502920" y="777240"/>
-            <a:ext cx="5669280" cy="3657600"/>
+            <a:ext cx="5669400" cy="3657600"/>
           </a:xfrm>
           <a:prstGeom prst="rect">
             <a:avLst/>
@@ -3587,6 +3587,56 @@
               <a:ea typeface="Calibri"/>
               <a:cs typeface="Calibri"/>
               <a:sym typeface="Calibri"/>
+            </a:endParaRPr>
+          </a:p>
+        </p:txBody>
+      </p:sp>
+      <p:sp>
+        <p:nvSpPr>
+          <p:cNvPr id="23" name="Google Shape;23;p1"/>
+          <p:cNvSpPr txBox="1"/>
+          <p:nvPr/>
+        </p:nvSpPr>
+        <p:spPr>
+          <a:xfrm>
+            <a:off x="832100" y="3070275"/>
+            <a:ext cx="3274500" cy="684300"/>
+          </a:xfrm>
+          <a:prstGeom prst="rect">
+            <a:avLst/>
+          </a:prstGeom>
+          <a:noFill/>
+          <a:ln>
+            <a:noFill/>
+          </a:ln>
+        </p:spPr>
+        <p:txBody>
+          <a:bodyPr anchorCtr="0" anchor="t" bIns="91425" lIns="91425" spcFirstLastPara="1" rIns="91425" wrap="square" tIns="91425">
+            <a:noAutofit/>
+          </a:bodyPr>
+          <a:lstStyle/>
+          <a:p>
+            <a:pPr indent="0" lvl="0" marL="0" rtl="0" algn="l">
+              <a:spcBef>
+                <a:spcPts val="0"/>
+              </a:spcBef>
+              <a:spcAft>
+                <a:spcPts val="0"/>
+              </a:spcAft>
+              <a:buNone/>
+            </a:pPr>
+            <a:r>
+              <a:rPr lang="en-US">
+                <a:solidFill>
+                  <a:schemeClr val="accent3"/>
+                </a:solidFill>
+              </a:rPr>
+              <a:t>MJQbe WEB</a:t>
+            </a:r>
+            <a:endParaRPr>
+              <a:solidFill>
+                <a:schemeClr val="accent3"/>
+              </a:solidFill>
             </a:endParaRPr>
           </a:p>
         </p:txBody>
@@ -3611,7 +3661,7 @@
     </p:bg>
     <p:spTree>
       <p:nvGrpSpPr>
-        <p:cNvPr id="27" name="Shape 27"/>
+        <p:cNvPr id="28" name="Shape 28"/>
         <p:cNvGrpSpPr/>
         <p:nvPr/>
       </p:nvGrpSpPr>
@@ -3625,7 +3675,7 @@
       </p:grpSpPr>
       <p:sp>
         <p:nvSpPr>
-          <p:cNvPr id="28" name="Google Shape;28;p2"/>
+          <p:cNvPr id="29" name="Google Shape;29;p2"/>
           <p:cNvSpPr/>
           <p:nvPr/>
         </p:nvSpPr>
@@ -3674,7 +3724,7 @@
       </p:sp>
       <p:sp>
         <p:nvSpPr>
-          <p:cNvPr id="29" name="Google Shape;29;p2"/>
+          <p:cNvPr id="30" name="Google Shape;30;p2"/>
           <p:cNvSpPr/>
           <p:nvPr/>
         </p:nvSpPr>
@@ -3723,7 +3773,7 @@
       </p:sp>
       <p:sp>
         <p:nvSpPr>
-          <p:cNvPr id="30" name="Google Shape;30;p2"/>
+          <p:cNvPr id="31" name="Google Shape;31;p2"/>
           <p:cNvSpPr/>
           <p:nvPr/>
         </p:nvSpPr>
@@ -3786,7 +3836,7 @@
       </p:sp>
       <p:sp>
         <p:nvSpPr>
-          <p:cNvPr id="31" name="Google Shape;31;p2"/>
+          <p:cNvPr id="32" name="Google Shape;32;p2"/>
           <p:cNvSpPr/>
           <p:nvPr/>
         </p:nvSpPr>
@@ -3842,7 +3892,7 @@
       </p:sp>
       <p:sp>
         <p:nvSpPr>
-          <p:cNvPr id="32" name="Google Shape;32;p2"/>
+          <p:cNvPr id="33" name="Google Shape;33;p2"/>
           <p:cNvSpPr/>
           <p:nvPr/>
         </p:nvSpPr>
@@ -3891,7 +3941,7 @@
       </p:sp>
       <p:sp>
         <p:nvSpPr>
-          <p:cNvPr id="33" name="Google Shape;33;p2"/>
+          <p:cNvPr id="34" name="Google Shape;34;p2"/>
           <p:cNvSpPr/>
           <p:nvPr/>
         </p:nvSpPr>
@@ -3954,7 +4004,7 @@
       </p:sp>
       <p:cxnSp>
         <p:nvCxnSpPr>
-          <p:cNvPr id="34" name="Google Shape;34;p2"/>
+          <p:cNvPr id="35" name="Google Shape;35;p2"/>
           <p:cNvCxnSpPr/>
           <p:nvPr/>
         </p:nvCxnSpPr>
@@ -3980,7 +4030,7 @@
       </p:cxnSp>
       <p:sp>
         <p:nvSpPr>
-          <p:cNvPr id="35" name="Google Shape;35;p2"/>
+          <p:cNvPr id="36" name="Google Shape;36;p2"/>
           <p:cNvSpPr/>
           <p:nvPr/>
         </p:nvSpPr>
@@ -4029,7 +4079,7 @@
       </p:sp>
       <p:sp>
         <p:nvSpPr>
-          <p:cNvPr id="36" name="Google Shape;36;p2"/>
+          <p:cNvPr id="37" name="Google Shape;37;p2"/>
           <p:cNvSpPr/>
           <p:nvPr/>
         </p:nvSpPr>
@@ -4092,7 +4142,7 @@
       </p:sp>
       <p:sp>
         <p:nvSpPr>
-          <p:cNvPr id="37" name="Google Shape;37;p2"/>
+          <p:cNvPr id="38" name="Google Shape;38;p2"/>
           <p:cNvSpPr/>
           <p:nvPr/>
         </p:nvSpPr>
@@ -4148,7 +4198,7 @@
       </p:sp>
       <p:sp>
         <p:nvSpPr>
-          <p:cNvPr id="38" name="Google Shape;38;p2"/>
+          <p:cNvPr id="39" name="Google Shape;39;p2"/>
           <p:cNvSpPr/>
           <p:nvPr/>
         </p:nvSpPr>
@@ -4197,7 +4247,7 @@
       </p:sp>
       <p:sp>
         <p:nvSpPr>
-          <p:cNvPr id="39" name="Google Shape;39;p2"/>
+          <p:cNvPr id="40" name="Google Shape;40;p2"/>
           <p:cNvSpPr/>
           <p:nvPr/>
         </p:nvSpPr>
@@ -4260,7 +4310,7 @@
       </p:sp>
       <p:sp>
         <p:nvSpPr>
-          <p:cNvPr id="40" name="Google Shape;40;p2"/>
+          <p:cNvPr id="41" name="Google Shape;41;p2"/>
           <p:cNvSpPr/>
           <p:nvPr/>
         </p:nvSpPr>
@@ -4338,7 +4388,7 @@
       </p:sp>
       <p:sp>
         <p:nvSpPr>
-          <p:cNvPr id="41" name="Google Shape;41;p2"/>
+          <p:cNvPr id="42" name="Google Shape;42;p2"/>
           <p:cNvSpPr/>
           <p:nvPr/>
         </p:nvSpPr>
@@ -4387,7 +4437,7 @@
       </p:sp>
       <p:sp>
         <p:nvSpPr>
-          <p:cNvPr id="42" name="Google Shape;42;p2"/>
+          <p:cNvPr id="43" name="Google Shape;43;p2"/>
           <p:cNvSpPr/>
           <p:nvPr/>
         </p:nvSpPr>
@@ -4450,7 +4500,7 @@
       </p:sp>
       <p:sp>
         <p:nvSpPr>
-          <p:cNvPr id="43" name="Google Shape;43;p2"/>
+          <p:cNvPr id="44" name="Google Shape;44;p2"/>
           <p:cNvSpPr/>
           <p:nvPr/>
         </p:nvSpPr>
@@ -4506,7 +4556,7 @@
       </p:sp>
       <p:sp>
         <p:nvSpPr>
-          <p:cNvPr id="44" name="Google Shape;44;p2"/>
+          <p:cNvPr id="45" name="Google Shape;45;p2"/>
           <p:cNvSpPr/>
           <p:nvPr/>
         </p:nvSpPr>
@@ -4555,7 +4605,7 @@
       </p:sp>
       <p:sp>
         <p:nvSpPr>
-          <p:cNvPr id="45" name="Google Shape;45;p2"/>
+          <p:cNvPr id="46" name="Google Shape;46;p2"/>
           <p:cNvSpPr/>
           <p:nvPr/>
         </p:nvSpPr>
@@ -4626,7 +4676,7 @@
       </p:sp>
       <p:sp>
         <p:nvSpPr>
-          <p:cNvPr id="46" name="Google Shape;46;p2"/>
+          <p:cNvPr id="47" name="Google Shape;47;p2"/>
           <p:cNvSpPr/>
           <p:nvPr/>
         </p:nvSpPr>
@@ -4732,7 +4782,7 @@
       </p:sp>
       <p:sp>
         <p:nvSpPr>
-          <p:cNvPr id="47" name="Google Shape;47;p2"/>
+          <p:cNvPr id="48" name="Google Shape;48;p2"/>
           <p:cNvSpPr/>
           <p:nvPr/>
         </p:nvSpPr>
@@ -4781,7 +4831,7 @@
       </p:sp>
       <p:sp>
         <p:nvSpPr>
-          <p:cNvPr id="48" name="Google Shape;48;p2"/>
+          <p:cNvPr id="49" name="Google Shape;49;p2"/>
           <p:cNvSpPr/>
           <p:nvPr/>
         </p:nvSpPr>
@@ -4844,7 +4894,7 @@
       </p:sp>
       <p:sp>
         <p:nvSpPr>
-          <p:cNvPr id="49" name="Google Shape;49;p2"/>
+          <p:cNvPr id="50" name="Google Shape;50;p2"/>
           <p:cNvSpPr/>
           <p:nvPr/>
         </p:nvSpPr>
@@ -4900,7 +4950,7 @@
       </p:sp>
       <p:sp>
         <p:nvSpPr>
-          <p:cNvPr id="50" name="Google Shape;50;p2"/>
+          <p:cNvPr id="51" name="Google Shape;51;p2"/>
           <p:cNvSpPr/>
           <p:nvPr/>
         </p:nvSpPr>
@@ -4949,7 +4999,7 @@
       </p:sp>
       <p:sp>
         <p:nvSpPr>
-          <p:cNvPr id="51" name="Google Shape;51;p2"/>
+          <p:cNvPr id="52" name="Google Shape;52;p2"/>
           <p:cNvSpPr/>
           <p:nvPr/>
         </p:nvSpPr>
@@ -5024,7 +5074,7 @@
       </p:sp>
       <p:sp>
         <p:nvSpPr>
-          <p:cNvPr id="52" name="Google Shape;52;p2"/>
+          <p:cNvPr id="53" name="Google Shape;53;p2"/>
           <p:cNvSpPr/>
           <p:nvPr/>
         </p:nvSpPr>
@@ -5130,7 +5180,7 @@
       </p:sp>
       <p:sp>
         <p:nvSpPr>
-          <p:cNvPr id="53" name="Google Shape;53;p2"/>
+          <p:cNvPr id="54" name="Google Shape;54;p2"/>
           <p:cNvSpPr/>
           <p:nvPr/>
         </p:nvSpPr>
@@ -5179,7 +5229,7 @@
       </p:sp>
       <p:sp>
         <p:nvSpPr>
-          <p:cNvPr id="54" name="Google Shape;54;p2"/>
+          <p:cNvPr id="55" name="Google Shape;55;p2"/>
           <p:cNvSpPr/>
           <p:nvPr/>
         </p:nvSpPr>
@@ -5242,7 +5292,7 @@
       </p:sp>
       <p:sp>
         <p:nvSpPr>
-          <p:cNvPr id="55" name="Google Shape;55;p2"/>
+          <p:cNvPr id="56" name="Google Shape;56;p2"/>
           <p:cNvSpPr/>
           <p:nvPr/>
         </p:nvSpPr>
@@ -5298,7 +5348,7 @@
       </p:sp>
       <p:sp>
         <p:nvSpPr>
-          <p:cNvPr id="56" name="Google Shape;56;p2"/>
+          <p:cNvPr id="57" name="Google Shape;57;p2"/>
           <p:cNvSpPr/>
           <p:nvPr/>
         </p:nvSpPr>
@@ -5347,7 +5397,7 @@
       </p:sp>
       <p:sp>
         <p:nvSpPr>
-          <p:cNvPr id="57" name="Google Shape;57;p2"/>
+          <p:cNvPr id="58" name="Google Shape;58;p2"/>
           <p:cNvSpPr/>
           <p:nvPr/>
         </p:nvSpPr>
@@ -5422,7 +5472,7 @@
       </p:sp>
       <p:sp>
         <p:nvSpPr>
-          <p:cNvPr id="58" name="Google Shape;58;p2"/>
+          <p:cNvPr id="59" name="Google Shape;59;p2"/>
           <p:cNvSpPr/>
           <p:nvPr/>
         </p:nvSpPr>
@@ -5512,7 +5562,7 @@
                 <a:cs typeface="Calibri"/>
                 <a:sym typeface="Calibri"/>
               </a:rPr>
-              <a:t>Alignement CdC ↔ Contrat de classe,</a:t>
+              <a:t>Alignement CdC ↔ Contrat,</a:t>
             </a:r>
             <a:endParaRPr b="0" i="0" sz="950" u="none" cap="none" strike="noStrike">
               <a:solidFill>
@@ -5568,7 +5618,7 @@
       </p:sp>
       <p:pic>
         <p:nvPicPr>
-          <p:cNvPr id="59" name="Google Shape;59;p2"/>
+          <p:cNvPr id="60" name="Google Shape;60;p2"/>
           <p:cNvPicPr preferRelativeResize="0"/>
           <p:nvPr/>
         </p:nvPicPr>
@@ -5614,7 +5664,7 @@
     </p:bg>
     <p:spTree>
       <p:nvGrpSpPr>
-        <p:cNvPr id="64" name="Shape 64"/>
+        <p:cNvPr id="65" name="Shape 65"/>
         <p:cNvGrpSpPr/>
         <p:nvPr/>
       </p:nvGrpSpPr>
@@ -5628,7 +5678,7 @@
       </p:grpSpPr>
       <p:sp>
         <p:nvSpPr>
-          <p:cNvPr id="65" name="Google Shape;65;p3"/>
+          <p:cNvPr id="66" name="Google Shape;66;p3"/>
           <p:cNvSpPr/>
           <p:nvPr/>
         </p:nvSpPr>
@@ -5677,7 +5727,7 @@
       </p:sp>
       <p:sp>
         <p:nvSpPr>
-          <p:cNvPr id="66" name="Google Shape;66;p3"/>
+          <p:cNvPr id="67" name="Google Shape;67;p3"/>
           <p:cNvSpPr/>
           <p:nvPr/>
         </p:nvSpPr>
@@ -5726,7 +5776,7 @@
       </p:sp>
       <p:sp>
         <p:nvSpPr>
-          <p:cNvPr id="67" name="Google Shape;67;p3"/>
+          <p:cNvPr id="68" name="Google Shape;68;p3"/>
           <p:cNvSpPr/>
           <p:nvPr/>
         </p:nvSpPr>
@@ -5789,7 +5839,7 @@
       </p:sp>
       <p:sp>
         <p:nvSpPr>
-          <p:cNvPr id="68" name="Google Shape;68;p3"/>
+          <p:cNvPr id="69" name="Google Shape;69;p3"/>
           <p:cNvSpPr/>
           <p:nvPr/>
         </p:nvSpPr>
@@ -5845,7 +5895,7 @@
       </p:sp>
       <p:sp>
         <p:nvSpPr>
-          <p:cNvPr id="69" name="Google Shape;69;p3"/>
+          <p:cNvPr id="70" name="Google Shape;70;p3"/>
           <p:cNvSpPr/>
           <p:nvPr/>
         </p:nvSpPr>
@@ -5894,7 +5944,7 @@
       </p:sp>
       <p:sp>
         <p:nvSpPr>
-          <p:cNvPr id="70" name="Google Shape;70;p3"/>
+          <p:cNvPr id="71" name="Google Shape;71;p3"/>
           <p:cNvSpPr/>
           <p:nvPr/>
         </p:nvSpPr>
@@ -5941,7 +5991,7 @@
                 <a:cs typeface="Calibri"/>
                 <a:sym typeface="Calibri"/>
               </a:rPr>
-              <a:t>📋  Extrait — Sprints 1 et </a:t>
+              <a:t>📋  Extrait — Sprints 1 et 2</a:t>
             </a:r>
             <a:endParaRPr b="0" i="0" sz="1000" u="none" cap="none" strike="noStrike">
               <a:solidFill>
@@ -5957,7 +6007,7 @@
       </p:sp>
       <p:sp>
         <p:nvSpPr>
-          <p:cNvPr id="71" name="Google Shape;71;p3"/>
+          <p:cNvPr id="72" name="Google Shape;72;p3"/>
           <p:cNvSpPr/>
           <p:nvPr/>
         </p:nvSpPr>
@@ -6023,7 +6073,7 @@
       </p:sp>
       <p:sp>
         <p:nvSpPr>
-          <p:cNvPr id="72" name="Google Shape;72;p3"/>
+          <p:cNvPr id="73" name="Google Shape;73;p3"/>
           <p:cNvSpPr/>
           <p:nvPr/>
         </p:nvSpPr>
@@ -6129,7 +6179,7 @@
       </p:sp>
       <p:sp>
         <p:nvSpPr>
-          <p:cNvPr id="73" name="Google Shape;73;p3"/>
+          <p:cNvPr id="74" name="Google Shape;74;p3"/>
           <p:cNvSpPr/>
           <p:nvPr/>
         </p:nvSpPr>
@@ -6195,7 +6245,7 @@
       </p:sp>
       <p:sp>
         <p:nvSpPr>
-          <p:cNvPr id="74" name="Google Shape;74;p3"/>
+          <p:cNvPr id="75" name="Google Shape;75;p3"/>
           <p:cNvSpPr/>
           <p:nvPr/>
         </p:nvSpPr>
@@ -6261,7 +6311,7 @@
       </p:sp>
       <p:sp>
         <p:nvSpPr>
-          <p:cNvPr id="75" name="Google Shape;75;p3"/>
+          <p:cNvPr id="76" name="Google Shape;76;p3"/>
           <p:cNvSpPr/>
           <p:nvPr/>
         </p:nvSpPr>
@@ -6327,7 +6377,7 @@
       </p:sp>
       <p:sp>
         <p:nvSpPr>
-          <p:cNvPr id="76" name="Google Shape;76;p3"/>
+          <p:cNvPr id="77" name="Google Shape;77;p3"/>
           <p:cNvSpPr/>
           <p:nvPr/>
         </p:nvSpPr>
@@ -6393,7 +6443,7 @@
       </p:sp>
       <p:sp>
         <p:nvSpPr>
-          <p:cNvPr id="77" name="Google Shape;77;p3"/>
+          <p:cNvPr id="78" name="Google Shape;78;p3"/>
           <p:cNvSpPr/>
           <p:nvPr/>
         </p:nvSpPr>
@@ -6459,7 +6509,7 @@
       </p:sp>
       <p:sp>
         <p:nvSpPr>
-          <p:cNvPr id="78" name="Google Shape;78;p3"/>
+          <p:cNvPr id="79" name="Google Shape;79;p3"/>
           <p:cNvSpPr/>
           <p:nvPr/>
         </p:nvSpPr>
@@ -6525,7 +6575,7 @@
       </p:sp>
       <p:sp>
         <p:nvSpPr>
-          <p:cNvPr id="79" name="Google Shape;79;p3"/>
+          <p:cNvPr id="80" name="Google Shape;80;p3"/>
           <p:cNvSpPr/>
           <p:nvPr/>
         </p:nvSpPr>
@@ -6631,7 +6681,7 @@
       </p:sp>
       <p:sp>
         <p:nvSpPr>
-          <p:cNvPr id="80" name="Google Shape;80;p3"/>
+          <p:cNvPr id="81" name="Google Shape;81;p3"/>
           <p:cNvSpPr/>
           <p:nvPr/>
         </p:nvSpPr>
@@ -6687,7 +6737,7 @@
       </p:sp>
       <p:sp>
         <p:nvSpPr>
-          <p:cNvPr id="81" name="Google Shape;81;p3"/>
+          <p:cNvPr id="82" name="Google Shape;82;p3"/>
           <p:cNvSpPr/>
           <p:nvPr/>
         </p:nvSpPr>
@@ -6736,7 +6786,7 @@
       </p:sp>
       <p:sp>
         <p:nvSpPr>
-          <p:cNvPr id="82" name="Google Shape;82;p3"/>
+          <p:cNvPr id="83" name="Google Shape;83;p3"/>
           <p:cNvSpPr/>
           <p:nvPr/>
         </p:nvSpPr>
@@ -6799,7 +6849,7 @@
       </p:sp>
       <p:sp>
         <p:nvSpPr>
-          <p:cNvPr id="83" name="Google Shape;83;p3"/>
+          <p:cNvPr id="84" name="Google Shape;84;p3"/>
           <p:cNvSpPr/>
           <p:nvPr/>
         </p:nvSpPr>
@@ -6945,7 +6995,7 @@
       </p:sp>
       <p:sp>
         <p:nvSpPr>
-          <p:cNvPr id="84" name="Google Shape;84;p3"/>
+          <p:cNvPr id="85" name="Google Shape;85;p3"/>
           <p:cNvSpPr/>
           <p:nvPr/>
         </p:nvSpPr>
@@ -7001,7 +7051,7 @@
       </p:sp>
       <p:sp>
         <p:nvSpPr>
-          <p:cNvPr id="85" name="Google Shape;85;p3"/>
+          <p:cNvPr id="86" name="Google Shape;86;p3"/>
           <p:cNvSpPr/>
           <p:nvPr/>
         </p:nvSpPr>
@@ -7050,7 +7100,7 @@
       </p:sp>
       <p:sp>
         <p:nvSpPr>
-          <p:cNvPr id="86" name="Google Shape;86;p3"/>
+          <p:cNvPr id="87" name="Google Shape;87;p3"/>
           <p:cNvSpPr/>
           <p:nvPr/>
         </p:nvSpPr>
@@ -7113,7 +7163,7 @@
       </p:sp>
       <p:sp>
         <p:nvSpPr>
-          <p:cNvPr id="87" name="Google Shape;87;p3"/>
+          <p:cNvPr id="88" name="Google Shape;88;p3"/>
           <p:cNvSpPr/>
           <p:nvPr/>
         </p:nvSpPr>
@@ -7259,7 +7309,7 @@
       </p:sp>
       <p:sp>
         <p:nvSpPr>
-          <p:cNvPr id="88" name="Google Shape;88;p3"/>
+          <p:cNvPr id="89" name="Google Shape;89;p3"/>
           <p:cNvSpPr/>
           <p:nvPr/>
         </p:nvSpPr>
@@ -7315,7 +7365,7 @@
       </p:sp>
       <p:sp>
         <p:nvSpPr>
-          <p:cNvPr id="89" name="Google Shape;89;p3"/>
+          <p:cNvPr id="90" name="Google Shape;90;p3"/>
           <p:cNvSpPr/>
           <p:nvPr/>
         </p:nvSpPr>
@@ -7364,7 +7414,7 @@
       </p:sp>
       <p:sp>
         <p:nvSpPr>
-          <p:cNvPr id="90" name="Google Shape;90;p3"/>
+          <p:cNvPr id="91" name="Google Shape;91;p3"/>
           <p:cNvSpPr/>
           <p:nvPr/>
         </p:nvSpPr>
@@ -7427,7 +7477,7 @@
       </p:sp>
       <p:sp>
         <p:nvSpPr>
-          <p:cNvPr id="91" name="Google Shape;91;p3"/>
+          <p:cNvPr id="92" name="Google Shape;92;p3"/>
           <p:cNvSpPr/>
           <p:nvPr/>
         </p:nvSpPr>
@@ -7609,7 +7659,7 @@
       </p:sp>
       <p:pic>
         <p:nvPicPr>
-          <p:cNvPr id="92" name="Google Shape;92;p3"/>
+          <p:cNvPr id="93" name="Google Shape;93;p3"/>
           <p:cNvPicPr preferRelativeResize="0"/>
           <p:nvPr/>
         </p:nvPicPr>
@@ -7655,7 +7705,7 @@
     </p:bg>
     <p:spTree>
       <p:nvGrpSpPr>
-        <p:cNvPr id="97" name="Shape 97"/>
+        <p:cNvPr id="98" name="Shape 98"/>
         <p:cNvGrpSpPr/>
         <p:nvPr/>
       </p:nvGrpSpPr>
@@ -7669,7 +7719,7 @@
       </p:grpSpPr>
       <p:sp>
         <p:nvSpPr>
-          <p:cNvPr id="98" name="Google Shape;98;p4"/>
+          <p:cNvPr id="99" name="Google Shape;99;p4"/>
           <p:cNvSpPr/>
           <p:nvPr/>
         </p:nvSpPr>
@@ -7718,7 +7768,7 @@
       </p:sp>
       <p:sp>
         <p:nvSpPr>
-          <p:cNvPr id="99" name="Google Shape;99;p4"/>
+          <p:cNvPr id="100" name="Google Shape;100;p4"/>
           <p:cNvSpPr/>
           <p:nvPr/>
         </p:nvSpPr>
@@ -7767,7 +7817,7 @@
       </p:sp>
       <p:sp>
         <p:nvSpPr>
-          <p:cNvPr id="100" name="Google Shape;100;p4"/>
+          <p:cNvPr id="101" name="Google Shape;101;p4"/>
           <p:cNvSpPr/>
           <p:nvPr/>
         </p:nvSpPr>
@@ -7830,7 +7880,7 @@
       </p:sp>
       <p:sp>
         <p:nvSpPr>
-          <p:cNvPr id="101" name="Google Shape;101;p4"/>
+          <p:cNvPr id="102" name="Google Shape;102;p4"/>
           <p:cNvSpPr/>
           <p:nvPr/>
         </p:nvSpPr>
@@ -7879,7 +7929,7 @@
       </p:sp>
       <p:sp>
         <p:nvSpPr>
-          <p:cNvPr id="102" name="Google Shape;102;p4"/>
+          <p:cNvPr id="103" name="Google Shape;103;p4"/>
           <p:cNvSpPr/>
           <p:nvPr/>
         </p:nvSpPr>
@@ -7928,7 +7978,7 @@
       </p:sp>
       <p:sp>
         <p:nvSpPr>
-          <p:cNvPr id="103" name="Google Shape;103;p4"/>
+          <p:cNvPr id="104" name="Google Shape;104;p4"/>
           <p:cNvSpPr/>
           <p:nvPr/>
         </p:nvSpPr>
@@ -7977,7 +8027,7 @@
       </p:sp>
       <p:sp>
         <p:nvSpPr>
-          <p:cNvPr id="104" name="Google Shape;104;p4"/>
+          <p:cNvPr id="105" name="Google Shape;105;p4"/>
           <p:cNvSpPr/>
           <p:nvPr/>
         </p:nvSpPr>
@@ -8083,7 +8133,7 @@
       </p:sp>
       <p:sp>
         <p:nvSpPr>
-          <p:cNvPr id="105" name="Google Shape;105;p4"/>
+          <p:cNvPr id="106" name="Google Shape;106;p4"/>
           <p:cNvSpPr/>
           <p:nvPr/>
         </p:nvSpPr>
@@ -8132,7 +8182,7 @@
       </p:sp>
       <p:sp>
         <p:nvSpPr>
-          <p:cNvPr id="106" name="Google Shape;106;p4"/>
+          <p:cNvPr id="107" name="Google Shape;107;p4"/>
           <p:cNvSpPr/>
           <p:nvPr/>
         </p:nvSpPr>
@@ -8238,7 +8288,7 @@
       </p:sp>
       <p:cxnSp>
         <p:nvCxnSpPr>
-          <p:cNvPr id="107" name="Google Shape;107;p4"/>
+          <p:cNvPr id="108" name="Google Shape;108;p4"/>
           <p:cNvCxnSpPr/>
           <p:nvPr/>
         </p:nvCxnSpPr>
@@ -8264,7 +8314,7 @@
       </p:cxnSp>
       <p:sp>
         <p:nvSpPr>
-          <p:cNvPr id="108" name="Google Shape;108;p4"/>
+          <p:cNvPr id="109" name="Google Shape;109;p4"/>
           <p:cNvSpPr/>
           <p:nvPr/>
         </p:nvSpPr>
@@ -8320,7 +8370,7 @@
       </p:sp>
       <p:sp>
         <p:nvSpPr>
-          <p:cNvPr id="109" name="Google Shape;109;p4"/>
+          <p:cNvPr id="110" name="Google Shape;110;p4"/>
           <p:cNvSpPr/>
           <p:nvPr/>
         </p:nvSpPr>
@@ -8426,7 +8476,7 @@
       </p:sp>
       <p:sp>
         <p:nvSpPr>
-          <p:cNvPr id="110" name="Google Shape;110;p4"/>
+          <p:cNvPr id="111" name="Google Shape;111;p4"/>
           <p:cNvSpPr/>
           <p:nvPr/>
         </p:nvSpPr>
@@ -8482,7 +8532,7 @@
       </p:sp>
       <p:sp>
         <p:nvSpPr>
-          <p:cNvPr id="111" name="Google Shape;111;p4"/>
+          <p:cNvPr id="112" name="Google Shape;112;p4"/>
           <p:cNvSpPr/>
           <p:nvPr/>
         </p:nvSpPr>
@@ -8588,7 +8638,7 @@
       </p:sp>
       <p:cxnSp>
         <p:nvCxnSpPr>
-          <p:cNvPr id="112" name="Google Shape;112;p4"/>
+          <p:cNvPr id="113" name="Google Shape;113;p4"/>
           <p:cNvCxnSpPr/>
           <p:nvPr/>
         </p:nvCxnSpPr>
@@ -8614,7 +8664,7 @@
       </p:cxnSp>
       <p:sp>
         <p:nvSpPr>
-          <p:cNvPr id="113" name="Google Shape;113;p4"/>
+          <p:cNvPr id="114" name="Google Shape;114;p4"/>
           <p:cNvSpPr/>
           <p:nvPr/>
         </p:nvSpPr>
@@ -8670,7 +8720,7 @@
       </p:sp>
       <p:sp>
         <p:nvSpPr>
-          <p:cNvPr id="114" name="Google Shape;114;p4"/>
+          <p:cNvPr id="115" name="Google Shape;115;p4"/>
           <p:cNvSpPr/>
           <p:nvPr/>
         </p:nvSpPr>
@@ -8776,7 +8826,7 @@
       </p:sp>
       <p:cxnSp>
         <p:nvCxnSpPr>
-          <p:cNvPr id="115" name="Google Shape;115;p4"/>
+          <p:cNvPr id="116" name="Google Shape;116;p4"/>
           <p:cNvCxnSpPr/>
           <p:nvPr/>
         </p:nvCxnSpPr>
@@ -8802,7 +8852,7 @@
       </p:cxnSp>
       <p:sp>
         <p:nvSpPr>
-          <p:cNvPr id="116" name="Google Shape;116;p4"/>
+          <p:cNvPr id="117" name="Google Shape;117;p4"/>
           <p:cNvSpPr/>
           <p:nvPr/>
         </p:nvSpPr>
@@ -8858,7 +8908,7 @@
       </p:sp>
       <p:sp>
         <p:nvSpPr>
-          <p:cNvPr id="117" name="Google Shape;117;p4"/>
+          <p:cNvPr id="118" name="Google Shape;118;p4"/>
           <p:cNvSpPr/>
           <p:nvPr/>
         </p:nvSpPr>
@@ -8964,7 +9014,7 @@
       </p:sp>
       <p:sp>
         <p:nvSpPr>
-          <p:cNvPr id="118" name="Google Shape;118;p4"/>
+          <p:cNvPr id="119" name="Google Shape;119;p4"/>
           <p:cNvSpPr/>
           <p:nvPr/>
         </p:nvSpPr>
@@ -9020,7 +9070,7 @@
       </p:sp>
       <p:sp>
         <p:nvSpPr>
-          <p:cNvPr id="119" name="Google Shape;119;p4"/>
+          <p:cNvPr id="120" name="Google Shape;120;p4"/>
           <p:cNvSpPr/>
           <p:nvPr/>
         </p:nvSpPr>
@@ -9126,7 +9176,7 @@
       </p:sp>
       <p:sp>
         <p:nvSpPr>
-          <p:cNvPr id="120" name="Google Shape;120;p4"/>
+          <p:cNvPr id="121" name="Google Shape;121;p4"/>
           <p:cNvSpPr/>
           <p:nvPr/>
         </p:nvSpPr>
@@ -9182,7 +9232,7 @@
       </p:sp>
       <p:sp>
         <p:nvSpPr>
-          <p:cNvPr id="121" name="Google Shape;121;p4"/>
+          <p:cNvPr id="122" name="Google Shape;122;p4"/>
           <p:cNvSpPr/>
           <p:nvPr/>
         </p:nvSpPr>
@@ -9328,7 +9378,7 @@
       </p:sp>
       <p:sp>
         <p:nvSpPr>
-          <p:cNvPr id="122" name="Google Shape;122;p4"/>
+          <p:cNvPr id="123" name="Google Shape;123;p4"/>
           <p:cNvSpPr/>
           <p:nvPr/>
         </p:nvSpPr>
@@ -9384,7 +9434,7 @@
       </p:sp>
       <p:sp>
         <p:nvSpPr>
-          <p:cNvPr id="123" name="Google Shape;123;p4"/>
+          <p:cNvPr id="124" name="Google Shape;124;p4"/>
           <p:cNvSpPr/>
           <p:nvPr/>
         </p:nvSpPr>
@@ -9434,7 +9484,19 @@
                 <a:cs typeface="Calibri"/>
                 <a:sym typeface="Calibri"/>
               </a:rPr>
-              <a:t>Corrige /</a:t>
+              <a:t>Corrige </a:t>
+            </a:r>
+            <a:r>
+              <a:rPr b="1" lang="en-US" sz="950">
+                <a:solidFill>
+                  <a:srgbClr val="19B39A"/>
+                </a:solidFill>
+                <a:latin typeface="Calibri"/>
+                <a:ea typeface="Calibri"/>
+                <a:cs typeface="Calibri"/>
+                <a:sym typeface="Calibri"/>
+              </a:rPr>
+              <a:t>ou </a:t>
             </a:r>
             <a:endParaRPr b="0" i="0" sz="950" u="none" cap="none" strike="noStrike">
               <a:solidFill>
@@ -9490,10 +9552,10 @@
       </p:sp>
       <p:cxnSp>
         <p:nvCxnSpPr>
-          <p:cNvPr id="124" name="Google Shape;124;p4"/>
+          <p:cNvPr id="125" name="Google Shape;125;p4"/>
           <p:cNvCxnSpPr>
-            <a:stCxn id="123" idx="3"/>
-            <a:endCxn id="121" idx="1"/>
+            <a:stCxn id="124" idx="3"/>
+            <a:endCxn id="122" idx="1"/>
           </p:cNvCxnSpPr>
           <p:nvPr/>
         </p:nvCxnSpPr>
@@ -9519,7 +9581,7 @@
       </p:cxnSp>
       <p:sp>
         <p:nvSpPr>
-          <p:cNvPr id="125" name="Google Shape;125;p4"/>
+          <p:cNvPr id="126" name="Google Shape;126;p4"/>
           <p:cNvSpPr/>
           <p:nvPr/>
         </p:nvSpPr>
@@ -9575,7 +9637,7 @@
       </p:sp>
       <p:sp>
         <p:nvSpPr>
-          <p:cNvPr id="126" name="Google Shape;126;p4"/>
+          <p:cNvPr id="127" name="Google Shape;127;p4"/>
           <p:cNvSpPr/>
           <p:nvPr/>
         </p:nvSpPr>
@@ -9681,7 +9743,7 @@
       </p:sp>
       <p:sp>
         <p:nvSpPr>
-          <p:cNvPr id="127" name="Google Shape;127;p4"/>
+          <p:cNvPr id="128" name="Google Shape;128;p4"/>
           <p:cNvSpPr/>
           <p:nvPr/>
         </p:nvSpPr>
@@ -9737,7 +9799,7 @@
       </p:sp>
       <p:sp>
         <p:nvSpPr>
-          <p:cNvPr id="128" name="Google Shape;128;p4"/>
+          <p:cNvPr id="129" name="Google Shape;129;p4"/>
           <p:cNvSpPr/>
           <p:nvPr/>
         </p:nvSpPr>
@@ -9891,10 +9953,10 @@
       </p:sp>
       <p:cxnSp>
         <p:nvCxnSpPr>
-          <p:cNvPr id="129" name="Google Shape;129;p4"/>
+          <p:cNvPr id="130" name="Google Shape;130;p4"/>
           <p:cNvCxnSpPr>
-            <a:stCxn id="128" idx="3"/>
-            <a:endCxn id="130" idx="1"/>
+            <a:stCxn id="129" idx="3"/>
+            <a:endCxn id="131" idx="1"/>
           </p:cNvCxnSpPr>
           <p:nvPr/>
         </p:nvCxnSpPr>
@@ -9920,7 +9982,7 @@
       </p:cxnSp>
       <p:sp>
         <p:nvSpPr>
-          <p:cNvPr id="131" name="Google Shape;131;p4"/>
+          <p:cNvPr id="132" name="Google Shape;132;p4"/>
           <p:cNvSpPr/>
           <p:nvPr/>
         </p:nvSpPr>
@@ -9976,7 +10038,7 @@
       </p:sp>
       <p:sp>
         <p:nvSpPr>
-          <p:cNvPr id="130" name="Google Shape;130;p4"/>
+          <p:cNvPr id="131" name="Google Shape;131;p4"/>
           <p:cNvSpPr/>
           <p:nvPr/>
         </p:nvSpPr>
@@ -10082,7 +10144,7 @@
       </p:sp>
       <p:cxnSp>
         <p:nvCxnSpPr>
-          <p:cNvPr id="132" name="Google Shape;132;p4"/>
+          <p:cNvPr id="133" name="Google Shape;133;p4"/>
           <p:cNvCxnSpPr/>
           <p:nvPr/>
         </p:nvCxnSpPr>
@@ -10108,7 +10170,7 @@
       </p:cxnSp>
       <p:cxnSp>
         <p:nvCxnSpPr>
-          <p:cNvPr id="133" name="Google Shape;133;p4"/>
+          <p:cNvPr id="134" name="Google Shape;134;p4"/>
           <p:cNvCxnSpPr/>
           <p:nvPr/>
         </p:nvCxnSpPr>
@@ -10134,10 +10196,10 @@
       </p:cxnSp>
       <p:cxnSp>
         <p:nvCxnSpPr>
-          <p:cNvPr id="134" name="Google Shape;134;p4"/>
+          <p:cNvPr id="135" name="Google Shape;135;p4"/>
           <p:cNvCxnSpPr>
-            <a:stCxn id="114" idx="3"/>
-            <a:endCxn id="121" idx="3"/>
+            <a:stCxn id="115" idx="3"/>
+            <a:endCxn id="122" idx="3"/>
           </p:cNvCxnSpPr>
           <p:nvPr/>
         </p:nvCxnSpPr>
@@ -10165,10 +10227,10 @@
       </p:cxnSp>
       <p:cxnSp>
         <p:nvCxnSpPr>
-          <p:cNvPr id="135" name="Google Shape;135;p4"/>
+          <p:cNvPr id="136" name="Google Shape;136;p4"/>
           <p:cNvCxnSpPr>
-            <a:stCxn id="111" idx="1"/>
-            <a:endCxn id="123" idx="1"/>
+            <a:stCxn id="112" idx="1"/>
+            <a:endCxn id="124" idx="1"/>
           </p:cNvCxnSpPr>
           <p:nvPr/>
         </p:nvCxnSpPr>
@@ -10196,10 +10258,10 @@
       </p:cxnSp>
       <p:cxnSp>
         <p:nvCxnSpPr>
-          <p:cNvPr id="136" name="Google Shape;136;p4"/>
+          <p:cNvPr id="137" name="Google Shape;137;p4"/>
           <p:cNvCxnSpPr>
-            <a:stCxn id="106" idx="3"/>
-            <a:endCxn id="128" idx="1"/>
+            <a:stCxn id="107" idx="3"/>
+            <a:endCxn id="129" idx="1"/>
           </p:cNvCxnSpPr>
           <p:nvPr/>
         </p:nvCxnSpPr>
@@ -10225,6 +10287,48 @@
           </a:ln>
         </p:spPr>
       </p:cxnSp>
+      <p:sp>
+        <p:nvSpPr>
+          <p:cNvPr id="138" name="Google Shape;138;p4"/>
+          <p:cNvSpPr txBox="1"/>
+          <p:nvPr/>
+        </p:nvSpPr>
+        <p:spPr>
+          <a:xfrm>
+            <a:off x="5013825" y="4645350"/>
+            <a:ext cx="4000500" cy="402600"/>
+          </a:xfrm>
+          <a:prstGeom prst="rect">
+            <a:avLst/>
+          </a:prstGeom>
+          <a:noFill/>
+          <a:ln>
+            <a:noFill/>
+          </a:ln>
+        </p:spPr>
+        <p:txBody>
+          <a:bodyPr anchorCtr="0" anchor="t" bIns="91425" lIns="91425" spcFirstLastPara="1" rIns="91425" wrap="square" tIns="91425">
+            <a:noAutofit/>
+          </a:bodyPr>
+          <a:lstStyle/>
+          <a:p>
+            <a:pPr indent="0" lvl="0" marL="0" rtl="0" algn="l">
+              <a:spcBef>
+                <a:spcPts val="0"/>
+              </a:spcBef>
+              <a:spcAft>
+                <a:spcPts val="0"/>
+              </a:spcAft>
+              <a:buNone/>
+            </a:pPr>
+            <a:r>
+              <a:rPr lang="en-US"/>
+              <a:t>Total de temps passé : ~ 16 h dont 8 h de cours</a:t>
+            </a:r>
+            <a:endParaRPr/>
+          </a:p>
+        </p:txBody>
+      </p:sp>
     </p:spTree>
   </p:cSld>
   <p:clrMapOvr>
@@ -10245,7 +10349,7 @@
     </p:bg>
     <p:spTree>
       <p:nvGrpSpPr>
-        <p:cNvPr id="141" name="Shape 141"/>
+        <p:cNvPr id="143" name="Shape 143"/>
         <p:cNvGrpSpPr/>
         <p:nvPr/>
       </p:nvGrpSpPr>
@@ -10259,7 +10363,7 @@
       </p:grpSpPr>
       <p:sp>
         <p:nvSpPr>
-          <p:cNvPr id="142" name="Google Shape;142;g3d21a676ba0_0_4"/>
+          <p:cNvPr id="144" name="Google Shape;144;g3d21a676ba0_0_4"/>
           <p:cNvSpPr/>
           <p:nvPr/>
         </p:nvSpPr>
@@ -10308,7 +10412,7 @@
       </p:sp>
       <p:sp>
         <p:nvSpPr>
-          <p:cNvPr id="143" name="Google Shape;143;g3d21a676ba0_0_4"/>
+          <p:cNvPr id="145" name="Google Shape;145;g3d21a676ba0_0_4"/>
           <p:cNvSpPr/>
           <p:nvPr/>
         </p:nvSpPr>
@@ -10357,7 +10461,7 @@
       </p:sp>
       <p:sp>
         <p:nvSpPr>
-          <p:cNvPr id="144" name="Google Shape;144;g3d21a676ba0_0_4"/>
+          <p:cNvPr id="146" name="Google Shape;146;g3d21a676ba0_0_4"/>
           <p:cNvSpPr/>
           <p:nvPr/>
         </p:nvSpPr>
@@ -10456,7 +10560,7 @@
       </p:sp>
       <p:sp>
         <p:nvSpPr>
-          <p:cNvPr id="145" name="Google Shape;145;g3d21a676ba0_0_4"/>
+          <p:cNvPr id="147" name="Google Shape;147;g3d21a676ba0_0_4"/>
           <p:cNvSpPr/>
           <p:nvPr/>
         </p:nvSpPr>
@@ -10512,7 +10616,7 @@
       </p:sp>
       <p:sp>
         <p:nvSpPr>
-          <p:cNvPr id="146" name="Google Shape;146;g3d21a676ba0_0_4"/>
+          <p:cNvPr id="148" name="Google Shape;148;g3d21a676ba0_0_4"/>
           <p:cNvSpPr/>
           <p:nvPr/>
         </p:nvSpPr>
@@ -10561,7 +10665,7 @@
       </p:sp>
       <p:sp>
         <p:nvSpPr>
-          <p:cNvPr id="147" name="Google Shape;147;g3d21a676ba0_0_4"/>
+          <p:cNvPr id="149" name="Google Shape;149;g3d21a676ba0_0_4"/>
           <p:cNvSpPr/>
           <p:nvPr/>
         </p:nvSpPr>
@@ -10667,7 +10771,7 @@
       </p:sp>
       <p:sp>
         <p:nvSpPr>
-          <p:cNvPr id="148" name="Google Shape;148;g3d21a676ba0_0_4"/>
+          <p:cNvPr id="150" name="Google Shape;150;g3d21a676ba0_0_4"/>
           <p:cNvSpPr/>
           <p:nvPr/>
         </p:nvSpPr>
@@ -10730,7 +10834,7 @@
       </p:sp>
       <p:sp>
         <p:nvSpPr>
-          <p:cNvPr id="149" name="Google Shape;149;g3d21a676ba0_0_4"/>
+          <p:cNvPr id="151" name="Google Shape;151;g3d21a676ba0_0_4"/>
           <p:cNvSpPr/>
           <p:nvPr/>
         </p:nvSpPr>
@@ -10786,7 +10890,7 @@
       </p:sp>
       <p:sp>
         <p:nvSpPr>
-          <p:cNvPr id="150" name="Google Shape;150;g3d21a676ba0_0_4"/>
+          <p:cNvPr id="152" name="Google Shape;152;g3d21a676ba0_0_4"/>
           <p:cNvSpPr/>
           <p:nvPr/>
         </p:nvSpPr>
@@ -10835,7 +10939,7 @@
       </p:sp>
       <p:sp>
         <p:nvSpPr>
-          <p:cNvPr id="151" name="Google Shape;151;g3d21a676ba0_0_4"/>
+          <p:cNvPr id="153" name="Google Shape;153;g3d21a676ba0_0_4"/>
           <p:cNvSpPr/>
           <p:nvPr/>
         </p:nvSpPr>
@@ -10922,7 +11026,7 @@
       </p:sp>
       <p:pic>
         <p:nvPicPr>
-          <p:cNvPr id="152" name="Google Shape;152;g3d21a676ba0_0_4"/>
+          <p:cNvPr id="154" name="Google Shape;154;g3d21a676ba0_0_4"/>
           <p:cNvPicPr preferRelativeResize="0"/>
           <p:nvPr/>
         </p:nvPicPr>
@@ -10950,7 +11054,7 @@
       </p:pic>
       <p:pic>
         <p:nvPicPr>
-          <p:cNvPr id="153" name="Google Shape;153;g3d21a676ba0_0_4"/>
+          <p:cNvPr id="155" name="Google Shape;155;g3d21a676ba0_0_4"/>
           <p:cNvPicPr preferRelativeResize="0"/>
           <p:nvPr/>
         </p:nvPicPr>
@@ -10978,7 +11082,7 @@
       </p:pic>
       <p:pic>
         <p:nvPicPr>
-          <p:cNvPr id="154" name="Google Shape;154;g3d21a676ba0_0_4" title="output-2.gif"/>
+          <p:cNvPr id="156" name="Google Shape;156;g3d21a676ba0_0_4" title="output-2.gif"/>
           <p:cNvPicPr preferRelativeResize="0"/>
           <p:nvPr/>
         </p:nvPicPr>
@@ -11024,7 +11128,7 @@
     </p:bg>
     <p:spTree>
       <p:nvGrpSpPr>
-        <p:cNvPr id="159" name="Shape 159"/>
+        <p:cNvPr id="161" name="Shape 161"/>
         <p:cNvGrpSpPr/>
         <p:nvPr/>
       </p:nvGrpSpPr>
@@ -11038,7 +11142,7 @@
       </p:grpSpPr>
       <p:sp>
         <p:nvSpPr>
-          <p:cNvPr id="160" name="Google Shape;160;p5"/>
+          <p:cNvPr id="162" name="Google Shape;162;p5"/>
           <p:cNvSpPr/>
           <p:nvPr/>
         </p:nvSpPr>
@@ -11087,7 +11191,7 @@
       </p:sp>
       <p:sp>
         <p:nvSpPr>
-          <p:cNvPr id="161" name="Google Shape;161;p5"/>
+          <p:cNvPr id="163" name="Google Shape;163;p5"/>
           <p:cNvSpPr/>
           <p:nvPr/>
         </p:nvSpPr>
@@ -11136,7 +11240,7 @@
       </p:sp>
       <p:sp>
         <p:nvSpPr>
-          <p:cNvPr id="162" name="Google Shape;162;p5"/>
+          <p:cNvPr id="164" name="Google Shape;164;p5"/>
           <p:cNvSpPr/>
           <p:nvPr/>
         </p:nvSpPr>
@@ -11223,7 +11327,7 @@
       </p:sp>
       <p:sp>
         <p:nvSpPr>
-          <p:cNvPr id="163" name="Google Shape;163;p5"/>
+          <p:cNvPr id="165" name="Google Shape;165;p5"/>
           <p:cNvSpPr/>
           <p:nvPr/>
         </p:nvSpPr>
@@ -11279,7 +11383,7 @@
       </p:sp>
       <p:sp>
         <p:nvSpPr>
-          <p:cNvPr id="164" name="Google Shape;164;p5"/>
+          <p:cNvPr id="166" name="Google Shape;166;p5"/>
           <p:cNvSpPr/>
           <p:nvPr/>
         </p:nvSpPr>
@@ -11328,7 +11432,7 @@
       </p:sp>
       <p:sp>
         <p:nvSpPr>
-          <p:cNvPr id="165" name="Google Shape;165;p5"/>
+          <p:cNvPr id="167" name="Google Shape;167;p5"/>
           <p:cNvSpPr/>
           <p:nvPr/>
         </p:nvSpPr>
@@ -11391,7 +11495,7 @@
       </p:sp>
       <p:sp>
         <p:nvSpPr>
-          <p:cNvPr id="166" name="Google Shape;166;p5"/>
+          <p:cNvPr id="168" name="Google Shape;168;p5"/>
           <p:cNvSpPr/>
           <p:nvPr/>
         </p:nvSpPr>
@@ -11497,7 +11601,7 @@
       </p:sp>
       <p:sp>
         <p:nvSpPr>
-          <p:cNvPr id="167" name="Google Shape;167;p5"/>
+          <p:cNvPr id="169" name="Google Shape;169;p5"/>
           <p:cNvSpPr/>
           <p:nvPr/>
         </p:nvSpPr>
@@ -11553,7 +11657,7 @@
       </p:sp>
       <p:sp>
         <p:nvSpPr>
-          <p:cNvPr id="168" name="Google Shape;168;p5"/>
+          <p:cNvPr id="170" name="Google Shape;170;p5"/>
           <p:cNvSpPr/>
           <p:nvPr/>
         </p:nvSpPr>
@@ -11602,7 +11706,7 @@
       </p:sp>
       <p:sp>
         <p:nvSpPr>
-          <p:cNvPr id="169" name="Google Shape;169;p5"/>
+          <p:cNvPr id="171" name="Google Shape;171;p5"/>
           <p:cNvSpPr/>
           <p:nvPr/>
         </p:nvSpPr>
@@ -11665,7 +11769,7 @@
       </p:sp>
       <p:sp>
         <p:nvSpPr>
-          <p:cNvPr id="170" name="Google Shape;170;p5"/>
+          <p:cNvPr id="172" name="Google Shape;172;p5"/>
           <p:cNvSpPr/>
           <p:nvPr/>
         </p:nvSpPr>
@@ -11771,7 +11875,7 @@
       </p:sp>
       <p:sp>
         <p:nvSpPr>
-          <p:cNvPr id="171" name="Google Shape;171;p5"/>
+          <p:cNvPr id="173" name="Google Shape;173;p5"/>
           <p:cNvSpPr/>
           <p:nvPr/>
         </p:nvSpPr>
@@ -11827,7 +11931,7 @@
       </p:sp>
       <p:sp>
         <p:nvSpPr>
-          <p:cNvPr id="172" name="Google Shape;172;p5"/>
+          <p:cNvPr id="174" name="Google Shape;174;p5"/>
           <p:cNvSpPr/>
           <p:nvPr/>
         </p:nvSpPr>
@@ -11876,7 +11980,7 @@
       </p:sp>
       <p:sp>
         <p:nvSpPr>
-          <p:cNvPr id="173" name="Google Shape;173;p5"/>
+          <p:cNvPr id="175" name="Google Shape;175;p5"/>
           <p:cNvSpPr/>
           <p:nvPr/>
         </p:nvSpPr>
@@ -11939,7 +12043,7 @@
       </p:sp>
       <p:sp>
         <p:nvSpPr>
-          <p:cNvPr id="174" name="Google Shape;174;p5"/>
+          <p:cNvPr id="176" name="Google Shape;176;p5"/>
           <p:cNvSpPr/>
           <p:nvPr/>
         </p:nvSpPr>
@@ -12045,7 +12149,7 @@
       </p:sp>
       <p:sp>
         <p:nvSpPr>
-          <p:cNvPr id="175" name="Google Shape;175;p5"/>
+          <p:cNvPr id="177" name="Google Shape;177;p5"/>
           <p:cNvSpPr/>
           <p:nvPr/>
         </p:nvSpPr>
@@ -12101,7 +12205,7 @@
       </p:sp>
       <p:sp>
         <p:nvSpPr>
-          <p:cNvPr id="176" name="Google Shape;176;p5"/>
+          <p:cNvPr id="178" name="Google Shape;178;p5"/>
           <p:cNvSpPr/>
           <p:nvPr/>
         </p:nvSpPr>
@@ -12150,7 +12254,7 @@
       </p:sp>
       <p:sp>
         <p:nvSpPr>
-          <p:cNvPr id="177" name="Google Shape;177;p5"/>
+          <p:cNvPr id="179" name="Google Shape;179;p5"/>
           <p:cNvSpPr/>
           <p:nvPr/>
         </p:nvSpPr>
@@ -12213,7 +12317,7 @@
       </p:sp>
       <p:sp>
         <p:nvSpPr>
-          <p:cNvPr id="178" name="Google Shape;178;p5"/>
+          <p:cNvPr id="180" name="Google Shape;180;p5"/>
           <p:cNvSpPr/>
           <p:nvPr/>
         </p:nvSpPr>
@@ -12319,7 +12423,7 @@
       </p:sp>
       <p:sp>
         <p:nvSpPr>
-          <p:cNvPr id="179" name="Google Shape;179;p5"/>
+          <p:cNvPr id="181" name="Google Shape;181;p5"/>
           <p:cNvSpPr/>
           <p:nvPr/>
         </p:nvSpPr>
@@ -12375,7 +12479,7 @@
       </p:sp>
       <p:sp>
         <p:nvSpPr>
-          <p:cNvPr id="180" name="Google Shape;180;p5"/>
+          <p:cNvPr id="182" name="Google Shape;182;p5"/>
           <p:cNvSpPr/>
           <p:nvPr/>
         </p:nvSpPr>
@@ -12424,7 +12528,7 @@
       </p:sp>
       <p:sp>
         <p:nvSpPr>
-          <p:cNvPr id="181" name="Google Shape;181;p5"/>
+          <p:cNvPr id="183" name="Google Shape;183;p5"/>
           <p:cNvSpPr/>
           <p:nvPr/>
         </p:nvSpPr>
@@ -12487,7 +12591,7 @@
       </p:sp>
       <p:sp>
         <p:nvSpPr>
-          <p:cNvPr id="182" name="Google Shape;182;p5"/>
+          <p:cNvPr id="184" name="Google Shape;184;p5"/>
           <p:cNvSpPr/>
           <p:nvPr/>
         </p:nvSpPr>
@@ -12633,7 +12737,7 @@
       </p:sp>
       <p:sp>
         <p:nvSpPr>
-          <p:cNvPr id="183" name="Google Shape;183;p5"/>
+          <p:cNvPr id="185" name="Google Shape;185;p5"/>
           <p:cNvSpPr/>
           <p:nvPr/>
         </p:nvSpPr>
@@ -12689,7 +12793,7 @@
       </p:sp>
       <p:sp>
         <p:nvSpPr>
-          <p:cNvPr id="184" name="Google Shape;184;p5"/>
+          <p:cNvPr id="186" name="Google Shape;186;p5"/>
           <p:cNvSpPr/>
           <p:nvPr/>
         </p:nvSpPr>
@@ -12738,7 +12842,7 @@
       </p:sp>
       <p:sp>
         <p:nvSpPr>
-          <p:cNvPr id="185" name="Google Shape;185;p5"/>
+          <p:cNvPr id="187" name="Google Shape;187;p5"/>
           <p:cNvSpPr/>
           <p:nvPr/>
         </p:nvSpPr>
@@ -12801,7 +12905,7 @@
       </p:sp>
       <p:sp>
         <p:nvSpPr>
-          <p:cNvPr id="186" name="Google Shape;186;p5"/>
+          <p:cNvPr id="188" name="Google Shape;188;p5"/>
           <p:cNvSpPr/>
           <p:nvPr/>
         </p:nvSpPr>

</xml_diff>